<commit_message>
Intro ING: la evaluacion de corte no se detalla en el deck, sin plataforma ni porcentajes
Co-Authored-By: Claude Opus 5.5 <noreply@anthropic.com>
</commit_message>
<xml_diff>
--- a/Introduccion a la Ingenieria/Clases/Clase 11 - Taller de prototipado inicial con IA/Presentacion.pptx
+++ b/Introduccion a la Ingenieria/Clases/Clase 11 - Taller de prototipado inicial con IA/Presentacion.pptx
@@ -14,7 +14,6 @@
     <p:sldId id="262" r:id="rId13"/>
     <p:sldId id="263" r:id="rId15"/>
     <p:sldId id="264" r:id="rId16"/>
-    <p:sldId id="265" r:id="rId17"/>
   </p:sldIdLst>
   <p:sldSz cx="12191695" cy="6858000" type="screen4x3"/>
   <p:notesSz cx="6858000" cy="9144000"/>
@@ -831,100 +830,6 @@
 </file>
 
 <file path=ppt/notesSlides/notesSlide5.xml><?xml version="1.0" encoding="utf-8"?>
-<p:notes xmlns:a="http://schemas.openxmlformats.org/drawingml/2006/main" xmlns:p="http://schemas.openxmlformats.org/presentationml/2006/main" xmlns:r="http://schemas.openxmlformats.org/officeDocument/2006/relationships">
-  <p:cSld>
-    <p:spTree>
-      <p:nvGrpSpPr>
-        <p:cNvPr id="1" name=""/>
-        <p:cNvGrpSpPr/>
-        <p:nvPr/>
-      </p:nvGrpSpPr>
-      <p:grpSpPr>
-        <a:xfrm>
-          <a:off x="0" y="0"/>
-          <a:ext cx="0" cy="0"/>
-          <a:chOff x="0" y="0"/>
-          <a:chExt cx="0" cy="0"/>
-        </a:xfrm>
-      </p:grpSpPr>
-      <p:sp>
-        <p:nvSpPr>
-          <p:cNvPr id="2" name="Slide Image Placeholder 1"/>
-          <p:cNvSpPr>
-            <a:spLocks noGrp="1"/>
-          </p:cNvSpPr>
-          <p:nvPr>
-            <p:ph type="sldImg" idx="2"/>
-          </p:nvPr>
-        </p:nvSpPr>
-        <p:spPr/>
-      </p:sp>
-      <p:sp>
-        <p:nvSpPr>
-          <p:cNvPr id="3" name="Notes Placeholder 2"/>
-          <p:cNvSpPr>
-            <a:spLocks noGrp="1"/>
-          </p:cNvSpPr>
-          <p:nvPr>
-            <p:ph type="body" idx="3" sz="quarter"/>
-          </p:nvPr>
-        </p:nvSpPr>
-        <p:spPr/>
-        <p:txBody>
-          <a:bodyPr/>
-          <a:lstStyle/>
-          <a:p>
-            <a:r>
-              <a:t>EL ANTES Y DESPUÉS, Y CÓMO CIERRA EL CORTE</a:t>
-            </a:r>
-          </a:p>
-          <a:p/>
-          <a:p>
-            <a:r>
-              <a:t>La diapositiva de antes y después es el corazón didáctico de la sesión, y hay que recorrerla con una insistencia: ninguna de las cinco propuestas del asistente era absurda. Cuentas de usuario, avisos por correo, reservas con historial, portadas, y un mensaje de error estándar: las cinco están en sistemas reales de bibliotecas en todo el mundo. Las cinco eran incorrectas para este proyecto, y cada una por una razón distinta que el equipo ya había escrito en una sesión anterior — el requisito «sin cuenta» de la sesión 7, la Ley 1581 de la sesión 4, el alcance mínimo de la sesión 8, el límite de 200 KB de la sesión 5, y la regla de mensajes con salida de la sesión 10.</a:t>
-            </a:r>
-          </a:p>
-          <a:p/>
-          <a:p>
-            <a:r>
-              <a:t>Ese es el hallazgo que hay que dejar dicho en voz alta, porque justifica todo el corte: el equipo pudo corregir al asistente porque tenía sus decisiones escritas. Un equipo sin requisitos no funcionales, sin alcance definido y sin indicador ambiental no habría tenido con qué objetar, y habría aceptado las cinco. La documentación de las sesiones 6 a 10 no era burocracia académica: es lo que hoy les permite ejercer criterio frente a una herramienta que suena más segura que ellos.</a:t>
-            </a:r>
-          </a:p>
-          <a:p/>
-          <a:p>
-            <a:r>
-              <a:t>El cierre del corte. Los últimos 20 minutos son la evaluación del corte 2 en ExamLab, individual y a libro abierto sobre sus propios documentos del equipo. Cubre las sesiones 7 a 11: fases y costo del cambio, requisitos y criterios de aceptación, matriz de decisión y alcance mínimo, calidad de fuentes, fidelidad de prototipos y uso responsable de IA. Que sea a libro abierto es deliberado y conviene explicarlo: premia al equipo que documentó, que es exactamente la conducta que el corte entero intentó enseñar.</a:t>
-            </a:r>
-          </a:p>
-          <a:p/>
-          <a:p>
-            <a:r>
-              <a:t>Hay que decir con claridad, como en la sesión 6, que ExamLab es la herramienta que usa este curso para las evaluaciones y no es una plataforma oficial de la universidad; el enlace se comparte en el chat en el momento y, si algo falla, la evaluación se reprograma y se avisa por el canal del curso. Y la advertencia final del taller, que hay que repetir aunque ya esté en la diapositiva: no se le pasan datos personales a un asistente —ni propios ni de terceros—, porque lo que se escribe ahí sale del computador y no vuelve.</a:t>
-            </a:r>
-          </a:p>
-        </p:txBody>
-      </p:sp>
-      <p:sp>
-        <p:nvSpPr>
-          <p:cNvPr id="4" name="Slide Number Placeholder 3"/>
-          <p:cNvSpPr>
-            <a:spLocks noGrp="1"/>
-          </p:cNvSpPr>
-          <p:nvPr>
-            <p:ph type="sldNum" idx="5" sz="quarter"/>
-          </p:nvPr>
-        </p:nvSpPr>
-        <p:spPr/>
-      </p:sp>
-    </p:spTree>
-  </p:cSld>
-  <p:clrMapOvr>
-    <a:masterClrMapping/>
-  </p:clrMapOvr>
-</p:notes>
-</file>
-
-<file path=ppt/notesSlides/notesSlide6.xml><?xml version="1.0" encoding="utf-8"?>
 <p:notes xmlns:a="http://schemas.openxmlformats.org/drawingml/2006/main" xmlns:p="http://schemas.openxmlformats.org/presentationml/2006/main" xmlns:r="http://schemas.openxmlformats.org/officeDocument/2006/relationships">
   <p:cSld>
     <p:spTree>
@@ -4384,222 +4289,6 @@
 </p:sld>
 </file>
 
-<file path=ppt/slides/slide10.xml><?xml version="1.0" encoding="utf-8"?>
-<p:sld xmlns:a="http://schemas.openxmlformats.org/drawingml/2006/main" xmlns:p="http://schemas.openxmlformats.org/presentationml/2006/main" xmlns:r="http://schemas.openxmlformats.org/officeDocument/2006/relationships">
-  <p:cSld>
-    <p:bg>
-      <p:bgPr>
-        <a:solidFill>
-          <a:srgbClr val="FFFFFF"/>
-        </a:solidFill>
-        <a:effectLst/>
-      </p:bgPr>
-    </p:bg>
-    <p:spTree>
-      <p:nvGrpSpPr>
-        <p:cNvPr id="1" name=""/>
-        <p:cNvGrpSpPr/>
-        <p:nvPr/>
-      </p:nvGrpSpPr>
-      <p:grpSpPr/>
-      <p:sp>
-        <p:nvSpPr>
-          <p:cNvPr id="2" name="Rectangle 1"/>
-          <p:cNvSpPr/>
-          <p:nvPr/>
-        </p:nvSpPr>
-        <p:spPr>
-          <a:xfrm>
-            <a:off x="0" y="0"/>
-            <a:ext cx="12191695" cy="164592"/>
-          </a:xfrm>
-          <a:prstGeom prst="rect">
-            <a:avLst/>
-          </a:prstGeom>
-          <a:solidFill>
-            <a:srgbClr val="269CCB"/>
-          </a:solidFill>
-          <a:ln>
-            <a:noFill/>
-          </a:ln>
-        </p:spPr>
-        <p:style>
-          <a:lnRef idx="1">
-            <a:schemeClr val="accent1"/>
-          </a:lnRef>
-          <a:fillRef idx="3">
-            <a:schemeClr val="accent1"/>
-          </a:fillRef>
-          <a:effectRef idx="2">
-            <a:schemeClr val="accent1"/>
-          </a:effectRef>
-          <a:fontRef idx="minor">
-            <a:schemeClr val="lt1"/>
-          </a:fontRef>
-        </p:style>
-        <p:txBody>
-          <a:bodyPr rtlCol="0" anchor="ctr"/>
-          <a:lstStyle/>
-          <a:p>
-            <a:pPr algn="ctr"/>
-          </a:p>
-        </p:txBody>
-      </p:sp>
-      <p:pic>
-        <p:nvPicPr>
-          <p:cNvPr id="3" name="Picture 2" descr="logo_uniajc_color.png"/>
-          <p:cNvPicPr>
-            <a:picLocks noChangeAspect="1"/>
-          </p:cNvPicPr>
-          <p:nvPr/>
-        </p:nvPicPr>
-        <p:blipFill>
-          <a:blip r:embed="rId2"/>
-          <a:stretch>
-            <a:fillRect/>
-          </a:stretch>
-        </p:blipFill>
-        <p:spPr>
-          <a:xfrm>
-            <a:off x="10271455" y="5998464"/>
-            <a:ext cx="1463040" cy="643233"/>
-          </a:xfrm>
-          <a:prstGeom prst="rect">
-            <a:avLst/>
-          </a:prstGeom>
-        </p:spPr>
-      </p:pic>
-      <p:sp>
-        <p:nvSpPr>
-          <p:cNvPr id="4" name="TextBox 3"/>
-          <p:cNvSpPr txBox="1"/>
-          <p:nvPr/>
-        </p:nvSpPr>
-        <p:spPr>
-          <a:xfrm>
-            <a:off x="457200" y="1737360"/>
-            <a:ext cx="11277295" cy="1097280"/>
-          </a:xfrm>
-          <a:prstGeom prst="rect">
-            <a:avLst/>
-          </a:prstGeom>
-          <a:noFill/>
-        </p:spPr>
-        <p:txBody>
-          <a:bodyPr wrap="square" anchor="ctr"/>
-          <a:lstStyle/>
-          <a:p>
-            <a:pPr algn="ctr"/>
-            <a:r>
-              <a:rPr sz="3400" b="1" i="0">
-                <a:solidFill>
-                  <a:srgbClr val="095292"/>
-                </a:solidFill>
-                <a:latin typeface="Calibri"/>
-              </a:rPr>
-              <a:t>Cierra el corte 2 · Nos vemos en la Clase 12</a:t>
-            </a:r>
-          </a:p>
-        </p:txBody>
-      </p:sp>
-      <p:sp>
-        <p:nvSpPr>
-          <p:cNvPr id="5" name="TextBox 4"/>
-          <p:cNvSpPr txBox="1"/>
-          <p:nvPr/>
-        </p:nvSpPr>
-        <p:spPr>
-          <a:xfrm>
-            <a:off x="457200" y="3017520"/>
-            <a:ext cx="11277295" cy="1645920"/>
-          </a:xfrm>
-          <a:prstGeom prst="rect">
-            <a:avLst/>
-          </a:prstGeom>
-          <a:noFill/>
-        </p:spPr>
-        <p:txBody>
-          <a:bodyPr wrap="square">
-            <a:spAutoFit/>
-          </a:bodyPr>
-          <a:lstStyle/>
-          <a:p>
-            <a:pPr algn="ctr">
-              <a:spcAft>
-                <a:spcPts val="600"/>
-              </a:spcAft>
-            </a:pPr>
-            <a:r>
-              <a:rPr sz="1600" b="0" i="0">
-                <a:solidFill>
-                  <a:srgbClr val="333333"/>
-                </a:solidFill>
-                <a:latin typeface="Calibri"/>
-              </a:rPr>
-              <a:t>Taller de prototipado inicial con IA · Clase 11</a:t>
-            </a:r>
-          </a:p>
-          <a:p>
-            <a:pPr algn="ctr">
-              <a:spcAft>
-                <a:spcPts val="600"/>
-              </a:spcAft>
-            </a:pPr>
-            <a:r>
-              <a:rPr sz="1600" b="0" i="0">
-                <a:solidFill>
-                  <a:srgbClr val="333333"/>
-                </a:solidFill>
-                <a:latin typeface="Calibri"/>
-              </a:rPr>
-              <a:t>FI300101 · UNIAJC · Ingeniería de Sistemas</a:t>
-            </a:r>
-          </a:p>
-        </p:txBody>
-      </p:sp>
-      <p:sp>
-        <p:nvSpPr>
-          <p:cNvPr id="6" name="TextBox 5"/>
-          <p:cNvSpPr txBox="1"/>
-          <p:nvPr/>
-        </p:nvSpPr>
-        <p:spPr>
-          <a:xfrm>
-            <a:off x="457200" y="4754880"/>
-            <a:ext cx="11277295" cy="640080"/>
-          </a:xfrm>
-          <a:prstGeom prst="rect">
-            <a:avLst/>
-          </a:prstGeom>
-          <a:noFill/>
-        </p:spPr>
-        <p:txBody>
-          <a:bodyPr wrap="square">
-            <a:spAutoFit/>
-          </a:bodyPr>
-          <a:lstStyle/>
-          <a:p>
-            <a:pPr algn="ctr"/>
-            <a:r>
-              <a:rPr sz="2000" b="1" i="0">
-                <a:solidFill>
-                  <a:srgbClr val="269CCB"/>
-                </a:solidFill>
-                <a:latin typeface="Calibri"/>
-              </a:rPr>
-              <a:t>Pudieron corregir al asistente porque tenían sus decisiones escritas</a:t>
-            </a:r>
-          </a:p>
-        </p:txBody>
-      </p:sp>
-    </p:spTree>
-  </p:cSld>
-  <p:clrMapOvr>
-    <a:masterClrMapping/>
-  </p:clrMapOvr>
-</p:sld>
-</file>
-
 <file path=ppt/slides/slide2.xml><?xml version="1.0" encoding="utf-8"?>
 <p:sld xmlns:a="http://schemas.openxmlformats.org/drawingml/2006/main" xmlns:p="http://schemas.openxmlformats.org/presentationml/2006/main" xmlns:r="http://schemas.openxmlformats.org/officeDocument/2006/relationships">
   <p:cSld>
@@ -5155,7 +4844,7 @@
                 </a:solidFill>
                 <a:latin typeface="Calibri"/>
               </a:rPr>
-              <a:t>Actividad en equipos — Prototipo v2 con IA, en salas de grupo</a:t>
+              <a:t>Actividad en equipos — opcional · la guía está en la carpeta de la clase</a:t>
             </a:r>
           </a:p>
         </p:txBody>
@@ -5270,7 +4959,7 @@
                 </a:solidFill>
                 <a:latin typeface="Calibri"/>
               </a:rPr>
-              <a:t>Exposiciones — 5 equipos × 3 min — lo que corrigieron a mano</a:t>
+              <a:t>Exposiciones — de la práctica, si se hizo</a:t>
             </a:r>
           </a:p>
         </p:txBody>
@@ -5385,7 +5074,7 @@
                 </a:solidFill>
                 <a:latin typeface="Calibri"/>
               </a:rPr>
-              <a:t>Evaluación de corte 2 — En la plataforma del curso · cubre las sesiones 7 a 11</a:t>
+              <a:t>Evaluación de corte 2 — sobre lo visto en el corte hasta hoy</a:t>
             </a:r>
           </a:p>
         </p:txBody>
@@ -5529,25 +5218,25 @@
           <a:p>
             <a:pPr algn="ctr"/>
             <a:r>
-              <a:rPr sz="1100" b="1" i="1">
+              <a:rPr sz="1200" b="1" i="1">
                 <a:solidFill>
                   <a:srgbClr val="666666"/>
                 </a:solidFill>
                 <a:latin typeface="Calibri"/>
               </a:rPr>
-              <a:t>Esta sesión cierra el corte 2 (30 %).</a:t>
-            </a:r>
-            <a:r>
-              <a:rPr sz="1100" b="0" i="1">
+              <a:t>Esta sesión cierra el corte 2.</a:t>
+            </a:r>
+            <a:r>
+              <a:rPr sz="1200" b="0" i="1">
                 <a:solidFill>
                   <a:srgbClr val="666666"/>
                 </a:solidFill>
                 <a:latin typeface="Calibri"/>
               </a:rPr>
-              <a:t> La teoría baja a 17 minutos y la actividad a 27 para que quepan los </a:t>
-            </a:r>
-            <a:r>
-              <a:rPr sz="1100" b="1" i="1">
+              <a:t> La teoría baja a 17 minutos para que quepan los </a:t>
+            </a:r>
+            <a:r>
+              <a:rPr sz="1200" b="1" i="1">
                 <a:solidFill>
                   <a:srgbClr val="666666"/>
                 </a:solidFill>
@@ -5556,16 +5245,16 @@
               <a:t>20 minutos de evaluación</a:t>
             </a:r>
             <a:r>
-              <a:rPr sz="1100" b="0" i="1">
+              <a:rPr sz="1200" b="0" i="1">
                 <a:solidFill>
                   <a:srgbClr val="666666"/>
                 </a:solidFill>
                 <a:latin typeface="Calibri"/>
               </a:rPr>
-              <a:t> al final, en la plataforma del curso, sobre las sesiones 7 a 11. Es además la </a:t>
-            </a:r>
-            <a:r>
-              <a:rPr sz="1100" b="1" i="1">
+              <a:t> al final, sobre lo visto en el corte hasta hoy. Es además la </a:t>
+            </a:r>
+            <a:r>
+              <a:rPr sz="1200" b="1" i="1">
                 <a:solidFill>
                   <a:srgbClr val="666666"/>
                 </a:solidFill>
@@ -5574,13 +5263,13 @@
               <a:t>segunda y última sesión con asistente de IA autorizado</a:t>
             </a:r>
             <a:r>
-              <a:rPr sz="1100" b="0" i="1">
+              <a:rPr sz="1200" b="0" i="1">
                 <a:solidFill>
                   <a:srgbClr val="666666"/>
                 </a:solidFill>
                 <a:latin typeface="Calibri"/>
               </a:rPr>
-              <a:t> —la otra fue la sesión 3—, y aplica la misma regla, hoy con más peso: se entrega el prompt usado y la lista de lo que se corrigió a mano.</a:t>
+              <a:t> —la otra fue la sesión 3—.</a:t>
             </a:r>
           </a:p>
         </p:txBody>
@@ -8026,7 +7715,7 @@
                 </a:solidFill>
                 <a:latin typeface="Calibri"/>
               </a:rPr>
-              <a:t>es el entregable</a:t>
+              <a:t>es lo que vale</a:t>
             </a:r>
             <a:r>
               <a:rPr sz="1300" b="0" i="0">
@@ -8035,7 +7724,7 @@
                 </a:solidFill>
                 <a:latin typeface="Calibri"/>
               </a:rPr>
-              <a:t>. Es la prueba de que ustedes pensaron, y es lo que más pesa en la rúbrica de hoy.</a:t>
+              <a:t>: es la prueba de que ustedes pensaron, y no la IA.</a:t>
             </a:r>
           </a:p>
         </p:txBody>
@@ -9748,172 +9437,7 @@
         <p:spPr>
           <a:xfrm>
             <a:off x="0" y="0"/>
-            <a:ext cx="12191695" cy="960120"/>
-          </a:xfrm>
-          <a:prstGeom prst="rect">
-            <a:avLst/>
-          </a:prstGeom>
-          <a:solidFill>
-            <a:srgbClr val="095292"/>
-          </a:solidFill>
-          <a:ln>
-            <a:noFill/>
-          </a:ln>
-        </p:spPr>
-        <p:style>
-          <a:lnRef idx="1">
-            <a:schemeClr val="accent1"/>
-          </a:lnRef>
-          <a:fillRef idx="3">
-            <a:schemeClr val="accent1"/>
-          </a:fillRef>
-          <a:effectRef idx="2">
-            <a:schemeClr val="accent1"/>
-          </a:effectRef>
-          <a:fontRef idx="minor">
-            <a:schemeClr val="lt1"/>
-          </a:fontRef>
-        </p:style>
-        <p:txBody>
-          <a:bodyPr rtlCol="0" anchor="ctr"/>
-          <a:lstStyle/>
-          <a:p>
-            <a:pPr algn="ctr"/>
-          </a:p>
-        </p:txBody>
-      </p:sp>
-      <p:sp>
-        <p:nvSpPr>
-          <p:cNvPr id="3" name="Rectangle 2"/>
-          <p:cNvSpPr/>
-          <p:nvPr/>
-        </p:nvSpPr>
-        <p:spPr>
-          <a:xfrm>
-            <a:off x="0" y="960120"/>
-            <a:ext cx="12191695" cy="41148"/>
-          </a:xfrm>
-          <a:prstGeom prst="rect">
-            <a:avLst/>
-          </a:prstGeom>
-          <a:solidFill>
-            <a:srgbClr val="FFD000"/>
-          </a:solidFill>
-          <a:ln>
-            <a:noFill/>
-          </a:ln>
-        </p:spPr>
-        <p:style>
-          <a:lnRef idx="1">
-            <a:schemeClr val="accent1"/>
-          </a:lnRef>
-          <a:fillRef idx="3">
-            <a:schemeClr val="accent1"/>
-          </a:fillRef>
-          <a:effectRef idx="2">
-            <a:schemeClr val="accent1"/>
-          </a:effectRef>
-          <a:fontRef idx="minor">
-            <a:schemeClr val="lt1"/>
-          </a:fontRef>
-        </p:style>
-        <p:txBody>
-          <a:bodyPr rtlCol="0" anchor="ctr"/>
-          <a:lstStyle/>
-          <a:p>
-            <a:pPr algn="ctr"/>
-          </a:p>
-        </p:txBody>
-      </p:sp>
-      <p:sp>
-        <p:nvSpPr>
-          <p:cNvPr id="4" name="TextBox 3"/>
-          <p:cNvSpPr txBox="1"/>
-          <p:nvPr/>
-        </p:nvSpPr>
-        <p:spPr>
-          <a:xfrm>
-            <a:off x="457200" y="164592"/>
-            <a:ext cx="11277295" cy="502920"/>
-          </a:xfrm>
-          <a:prstGeom prst="rect">
-            <a:avLst/>
-          </a:prstGeom>
-          <a:noFill/>
-        </p:spPr>
-        <p:txBody>
-          <a:bodyPr wrap="square">
-            <a:spAutoFit/>
-          </a:bodyPr>
-          <a:lstStyle/>
-          <a:p>
-            <a:r>
-              <a:rPr sz="2600" b="1" i="0">
-                <a:solidFill>
-                  <a:srgbClr val="FFFFFF"/>
-                </a:solidFill>
-                <a:latin typeface="Calibri"/>
-              </a:rPr>
-              <a:t>Cómo cierra el corte 2 hoy</a:t>
-            </a:r>
-          </a:p>
-        </p:txBody>
-      </p:sp>
-      <p:sp>
-        <p:nvSpPr>
-          <p:cNvPr id="5" name="Rounded Rectangle 4"/>
-          <p:cNvSpPr/>
-          <p:nvPr/>
-        </p:nvSpPr>
-        <p:spPr>
-          <a:xfrm>
-            <a:off x="457200" y="1261872"/>
-            <a:ext cx="11277295" cy="1051560"/>
-          </a:xfrm>
-          <a:prstGeom prst="roundRect">
-            <a:avLst>
-              <a:gd name="adj" fmla="val 12000"/>
-            </a:avLst>
-          </a:prstGeom>
-          <a:solidFill>
-            <a:srgbClr val="E8F4FA"/>
-          </a:solidFill>
-          <a:ln>
-            <a:noFill/>
-          </a:ln>
-        </p:spPr>
-        <p:style>
-          <a:lnRef idx="1">
-            <a:schemeClr val="accent1"/>
-          </a:lnRef>
-          <a:fillRef idx="3">
-            <a:schemeClr val="accent1"/>
-          </a:fillRef>
-          <a:effectRef idx="2">
-            <a:schemeClr val="accent1"/>
-          </a:effectRef>
-          <a:fontRef idx="minor">
-            <a:schemeClr val="lt1"/>
-          </a:fontRef>
-        </p:style>
-        <p:txBody>
-          <a:bodyPr rtlCol="0" anchor="ctr"/>
-          <a:lstStyle/>
-          <a:p>
-            <a:pPr algn="ctr"/>
-          </a:p>
-        </p:txBody>
-      </p:sp>
-      <p:sp>
-        <p:nvSpPr>
-          <p:cNvPr id="6" name="Rectangle 5"/>
-          <p:cNvSpPr/>
-          <p:nvPr/>
-        </p:nvSpPr>
-        <p:spPr>
-          <a:xfrm>
-            <a:off x="457200" y="1261872"/>
-            <a:ext cx="128016" cy="1051560"/>
+            <a:ext cx="12191695" cy="164592"/>
           </a:xfrm>
           <a:prstGeom prst="rect">
             <a:avLst/>
@@ -9947,16 +9471,73 @@
           </a:p>
         </p:txBody>
       </p:sp>
-      <p:sp>
-        <p:nvSpPr>
-          <p:cNvPr id="7" name="TextBox 6"/>
+      <p:pic>
+        <p:nvPicPr>
+          <p:cNvPr id="3" name="Picture 2" descr="logo_uniajc_color.png"/>
+          <p:cNvPicPr>
+            <a:picLocks noChangeAspect="1"/>
+          </p:cNvPicPr>
+          <p:nvPr/>
+        </p:nvPicPr>
+        <p:blipFill>
+          <a:blip r:embed="rId2"/>
+          <a:stretch>
+            <a:fillRect/>
+          </a:stretch>
+        </p:blipFill>
+        <p:spPr>
+          <a:xfrm>
+            <a:off x="10271455" y="5998464"/>
+            <a:ext cx="1463040" cy="643233"/>
+          </a:xfrm>
+          <a:prstGeom prst="rect">
+            <a:avLst/>
+          </a:prstGeom>
+        </p:spPr>
+      </p:pic>
+      <p:sp>
+        <p:nvSpPr>
+          <p:cNvPr id="4" name="TextBox 3"/>
           <p:cNvSpPr txBox="1"/>
           <p:nvPr/>
         </p:nvSpPr>
         <p:spPr>
           <a:xfrm>
-            <a:off x="777240" y="1399031"/>
-            <a:ext cx="10774375" cy="822959"/>
+            <a:off x="457200" y="1737360"/>
+            <a:ext cx="11277295" cy="1097280"/>
+          </a:xfrm>
+          <a:prstGeom prst="rect">
+            <a:avLst/>
+          </a:prstGeom>
+          <a:noFill/>
+        </p:spPr>
+        <p:txBody>
+          <a:bodyPr wrap="square" anchor="ctr"/>
+          <a:lstStyle/>
+          <a:p>
+            <a:pPr algn="ctr"/>
+            <a:r>
+              <a:rPr sz="3400" b="1" i="0">
+                <a:solidFill>
+                  <a:srgbClr val="095292"/>
+                </a:solidFill>
+                <a:latin typeface="Calibri"/>
+              </a:rPr>
+              <a:t>Cierra el corte 2 · Nos vemos en la Clase 12</a:t>
+            </a:r>
+          </a:p>
+        </p:txBody>
+      </p:sp>
+      <p:sp>
+        <p:nvSpPr>
+          <p:cNvPr id="5" name="TextBox 4"/>
+          <p:cNvSpPr txBox="1"/>
+          <p:nvPr/>
+        </p:nvSpPr>
+        <p:spPr>
+          <a:xfrm>
+            <a:off x="457200" y="3017520"/>
+            <a:ext cx="11277295" cy="1645920"/>
           </a:xfrm>
           <a:prstGeom prst="rect">
             <a:avLst/>
@@ -9969,159 +9550,49 @@
           </a:bodyPr>
           <a:lstStyle/>
           <a:p>
-            <a:r>
-              <a:rPr sz="1200" b="1" i="0">
-                <a:solidFill>
-                  <a:srgbClr val="269CCB"/>
-                </a:solidFill>
-                <a:latin typeface="Calibri"/>
-              </a:rPr>
-              <a:t>Info</a:t>
-            </a:r>
-          </a:p>
-          <a:p>
-            <a:pPr>
-              <a:spcBef>
-                <a:spcPts val="400"/>
-              </a:spcBef>
+            <a:pPr algn="ctr">
+              <a:spcAft>
+                <a:spcPts val="600"/>
+              </a:spcAft>
             </a:pPr>
             <a:r>
-              <a:rPr sz="1400" b="1" i="0">
+              <a:rPr sz="1600" b="0" i="0">
                 <a:solidFill>
                   <a:srgbClr val="333333"/>
                 </a:solidFill>
                 <a:latin typeface="Calibri"/>
               </a:rPr>
-              <a:t>Al final de la sesión hay 20 minutos de evaluación del corte 2</a:t>
-            </a:r>
-            <a:r>
-              <a:rPr sz="1400" b="0" i="0">
+              <a:t>Taller de prototipado inicial con IA · Clase 11</a:t>
+            </a:r>
+          </a:p>
+          <a:p>
+            <a:pPr algn="ctr">
+              <a:spcAft>
+                <a:spcPts val="600"/>
+              </a:spcAft>
+            </a:pPr>
+            <a:r>
+              <a:rPr sz="1600" b="0" i="0">
                 <a:solidFill>
                   <a:srgbClr val="333333"/>
                 </a:solidFill>
                 <a:latin typeface="Calibri"/>
               </a:rPr>
-              <a:t>, sobre las sesiones 7 a 11: ciclo de vida y costo del cambio, requisitos y criterios de aceptación, decisión entre alternativas y alcance mínimo, antecedentes y fuentes, prototipado y niveles de fidelidad, y uso responsable de IA. Es individual y a libro abierto: </a:t>
-            </a:r>
-            <a:r>
-              <a:rPr sz="1400" b="1" i="0">
-                <a:solidFill>
-                  <a:srgbClr val="333333"/>
-                </a:solidFill>
-                <a:latin typeface="Calibri"/>
-              </a:rPr>
-              <a:t>pueden consultar sus propios documentos del equipo</a:t>
-            </a:r>
-            <a:r>
-              <a:rPr sz="1400" b="0" i="0">
-                <a:solidFill>
-                  <a:srgbClr val="333333"/>
-                </a:solidFill>
-                <a:latin typeface="Calibri"/>
-              </a:rPr>
-              <a:t>.</a:t>
-            </a:r>
-          </a:p>
-        </p:txBody>
-      </p:sp>
-      <p:sp>
-        <p:nvSpPr>
-          <p:cNvPr id="8" name="Rounded Rectangle 7"/>
-          <p:cNvSpPr/>
-          <p:nvPr/>
-        </p:nvSpPr>
-        <p:spPr>
-          <a:xfrm>
-            <a:off x="457200" y="2478024"/>
-            <a:ext cx="11277295" cy="1051560"/>
-          </a:xfrm>
-          <a:prstGeom prst="roundRect">
-            <a:avLst>
-              <a:gd name="adj" fmla="val 12000"/>
-            </a:avLst>
-          </a:prstGeom>
-          <a:solidFill>
-            <a:srgbClr val="FFF8E1"/>
-          </a:solidFill>
-          <a:ln>
-            <a:noFill/>
-          </a:ln>
-        </p:spPr>
-        <p:style>
-          <a:lnRef idx="1">
-            <a:schemeClr val="accent1"/>
-          </a:lnRef>
-          <a:fillRef idx="3">
-            <a:schemeClr val="accent1"/>
-          </a:fillRef>
-          <a:effectRef idx="2">
-            <a:schemeClr val="accent1"/>
-          </a:effectRef>
-          <a:fontRef idx="minor">
-            <a:schemeClr val="lt1"/>
-          </a:fontRef>
-        </p:style>
-        <p:txBody>
-          <a:bodyPr rtlCol="0" anchor="ctr"/>
-          <a:lstStyle/>
-          <a:p>
-            <a:pPr algn="ctr"/>
-          </a:p>
-        </p:txBody>
-      </p:sp>
-      <p:sp>
-        <p:nvSpPr>
-          <p:cNvPr id="9" name="Rectangle 8"/>
-          <p:cNvSpPr/>
-          <p:nvPr/>
-        </p:nvSpPr>
-        <p:spPr>
-          <a:xfrm>
-            <a:off x="457200" y="2478024"/>
-            <a:ext cx="128016" cy="1051560"/>
-          </a:xfrm>
-          <a:prstGeom prst="rect">
-            <a:avLst/>
-          </a:prstGeom>
-          <a:solidFill>
-            <a:srgbClr val="FFD000"/>
-          </a:solidFill>
-          <a:ln>
-            <a:noFill/>
-          </a:ln>
-        </p:spPr>
-        <p:style>
-          <a:lnRef idx="1">
-            <a:schemeClr val="accent1"/>
-          </a:lnRef>
-          <a:fillRef idx="3">
-            <a:schemeClr val="accent1"/>
-          </a:fillRef>
-          <a:effectRef idx="2">
-            <a:schemeClr val="accent1"/>
-          </a:effectRef>
-          <a:fontRef idx="minor">
-            <a:schemeClr val="lt1"/>
-          </a:fontRef>
-        </p:style>
-        <p:txBody>
-          <a:bodyPr rtlCol="0" anchor="ctr"/>
-          <a:lstStyle/>
-          <a:p>
-            <a:pPr algn="ctr"/>
-          </a:p>
-        </p:txBody>
-      </p:sp>
-      <p:sp>
-        <p:nvSpPr>
-          <p:cNvPr id="10" name="TextBox 9"/>
+              <a:t>FI300101 · UNIAJC · Ingeniería de Sistemas</a:t>
+            </a:r>
+          </a:p>
+        </p:txBody>
+      </p:sp>
+      <p:sp>
+        <p:nvSpPr>
+          <p:cNvPr id="6" name="TextBox 5"/>
           <p:cNvSpPr txBox="1"/>
           <p:nvPr/>
         </p:nvSpPr>
         <p:spPr>
           <a:xfrm>
-            <a:off x="777240" y="2615184"/>
-            <a:ext cx="10774375" cy="822959"/>
+            <a:off x="457200" y="4754880"/>
+            <a:ext cx="11277295" cy="640080"/>
           </a:xfrm>
           <a:prstGeom prst="rect">
             <a:avLst/>
@@ -10134,239 +9605,15 @@
           </a:bodyPr>
           <a:lstStyle/>
           <a:p>
-            <a:r>
-              <a:rPr sz="1200" b="1" i="0">
-                <a:solidFill>
-                  <a:srgbClr val="FFD000"/>
-                </a:solidFill>
-                <a:latin typeface="Calibri"/>
-              </a:rPr>
-              <a:t>Aclaración</a:t>
-            </a:r>
-          </a:p>
-          <a:p>
-            <a:pPr>
-              <a:spcBef>
-                <a:spcPts val="400"/>
-              </a:spcBef>
-            </a:pPr>
-            <a:r>
-              <a:rPr sz="1400" b="1" i="0">
-                <a:solidFill>
-                  <a:srgbClr val="333333"/>
-                </a:solidFill>
-                <a:latin typeface="Calibri"/>
-              </a:rPr>
-              <a:t>La evaluación se aplica en la plataforma del curso</a:t>
-            </a:r>
-            <a:r>
-              <a:rPr sz="1400" b="0" i="0">
-                <a:solidFill>
-                  <a:srgbClr val="333333"/>
-                </a:solidFill>
-                <a:latin typeface="Calibri"/>
-              </a:rPr>
-              <a:t>, que es la herramienta que usa este curso para las evaluaciones y </a:t>
-            </a:r>
-            <a:r>
-              <a:rPr sz="1400" b="1" i="0">
-                <a:solidFill>
-                  <a:srgbClr val="333333"/>
-                </a:solidFill>
-                <a:latin typeface="Calibri"/>
-              </a:rPr>
-              <a:t>no es una plataforma oficial de la universidad</a:t>
-            </a:r>
-            <a:r>
-              <a:rPr sz="1400" b="0" i="0">
-                <a:solidFill>
-                  <a:srgbClr val="333333"/>
-                </a:solidFill>
-                <a:latin typeface="Calibri"/>
-              </a:rPr>
-              <a:t>. El enlace se comparte en el chat en el momento; si algo falla, la evaluación se reprograma y se avisa por el canal del curso.</a:t>
-            </a:r>
-          </a:p>
-        </p:txBody>
-      </p:sp>
-      <p:sp>
-        <p:nvSpPr>
-          <p:cNvPr id="11" name="Rounded Rectangle 10"/>
-          <p:cNvSpPr/>
-          <p:nvPr/>
-        </p:nvSpPr>
-        <p:spPr>
-          <a:xfrm>
-            <a:off x="457200" y="3694176"/>
-            <a:ext cx="11277295" cy="1051560"/>
-          </a:xfrm>
-          <a:prstGeom prst="roundRect">
-            <a:avLst>
-              <a:gd name="adj" fmla="val 12000"/>
-            </a:avLst>
-          </a:prstGeom>
-          <a:solidFill>
-            <a:srgbClr val="FBE4E4"/>
-          </a:solidFill>
-          <a:ln>
-            <a:noFill/>
-          </a:ln>
-        </p:spPr>
-        <p:style>
-          <a:lnRef idx="1">
-            <a:schemeClr val="accent1"/>
-          </a:lnRef>
-          <a:fillRef idx="3">
-            <a:schemeClr val="accent1"/>
-          </a:fillRef>
-          <a:effectRef idx="2">
-            <a:schemeClr val="accent1"/>
-          </a:effectRef>
-          <a:fontRef idx="minor">
-            <a:schemeClr val="lt1"/>
-          </a:fontRef>
-        </p:style>
-        <p:txBody>
-          <a:bodyPr rtlCol="0" anchor="ctr"/>
-          <a:lstStyle/>
-          <a:p>
             <a:pPr algn="ctr"/>
-          </a:p>
-        </p:txBody>
-      </p:sp>
-      <p:sp>
-        <p:nvSpPr>
-          <p:cNvPr id="12" name="Rectangle 11"/>
-          <p:cNvSpPr/>
-          <p:nvPr/>
-        </p:nvSpPr>
-        <p:spPr>
-          <a:xfrm>
-            <a:off x="457200" y="3694176"/>
-            <a:ext cx="128016" cy="1051560"/>
-          </a:xfrm>
-          <a:prstGeom prst="rect">
-            <a:avLst/>
-          </a:prstGeom>
-          <a:solidFill>
-            <a:srgbClr val="A02030"/>
-          </a:solidFill>
-          <a:ln>
-            <a:noFill/>
-          </a:ln>
-        </p:spPr>
-        <p:style>
-          <a:lnRef idx="1">
-            <a:schemeClr val="accent1"/>
-          </a:lnRef>
-          <a:fillRef idx="3">
-            <a:schemeClr val="accent1"/>
-          </a:fillRef>
-          <a:effectRef idx="2">
-            <a:schemeClr val="accent1"/>
-          </a:effectRef>
-          <a:fontRef idx="minor">
-            <a:schemeClr val="lt1"/>
-          </a:fontRef>
-        </p:style>
-        <p:txBody>
-          <a:bodyPr rtlCol="0" anchor="ctr"/>
-          <a:lstStyle/>
-          <a:p>
-            <a:pPr algn="ctr"/>
-          </a:p>
-        </p:txBody>
-      </p:sp>
-      <p:sp>
-        <p:nvSpPr>
-          <p:cNvPr id="13" name="TextBox 12"/>
-          <p:cNvSpPr txBox="1"/>
-          <p:nvPr/>
-        </p:nvSpPr>
-        <p:spPr>
-          <a:xfrm>
-            <a:off x="777240" y="3831336"/>
-            <a:ext cx="10774375" cy="822959"/>
-          </a:xfrm>
-          <a:prstGeom prst="rect">
-            <a:avLst/>
-          </a:prstGeom>
-          <a:noFill/>
-        </p:spPr>
-        <p:txBody>
-          <a:bodyPr wrap="square">
-            <a:spAutoFit/>
-          </a:bodyPr>
-          <a:lstStyle/>
-          <a:p>
-            <a:r>
-              <a:rPr sz="1200" b="1" i="0">
-                <a:solidFill>
-                  <a:srgbClr val="A02030"/>
-                </a:solidFill>
-                <a:latin typeface="Calibri"/>
-              </a:rPr>
-              <a:t>Atención</a:t>
-            </a:r>
-          </a:p>
-          <a:p>
-            <a:pPr>
-              <a:spcBef>
-                <a:spcPts val="400"/>
-              </a:spcBef>
-            </a:pPr>
-            <a:r>
-              <a:rPr sz="1400" b="1" i="0">
-                <a:solidFill>
-                  <a:srgbClr val="333333"/>
-                </a:solidFill>
-                <a:latin typeface="Calibri"/>
-              </a:rPr>
-              <a:t>Lo que se califica hoy del taller no es la variante de la IA: es lo que corrigieron.</a:t>
-            </a:r>
-            <a:r>
-              <a:rPr sz="1400" b="0" i="0">
-                <a:solidFill>
-                  <a:srgbClr val="333333"/>
-                </a:solidFill>
-                <a:latin typeface="Calibri"/>
-              </a:rPr>
-              <a:t> Un equipo que entrega tal cual lo que devolvió el asistente tiene la nota más baja del corte, aunque se vea bien. Y no se le pasan datos personales a un asistente: lo que se escribe ahí sale del computador y no vuelve.</a:t>
-            </a:r>
-          </a:p>
-        </p:txBody>
-      </p:sp>
-      <p:sp>
-        <p:nvSpPr>
-          <p:cNvPr id="14" name="TextBox 13"/>
-          <p:cNvSpPr txBox="1"/>
-          <p:nvPr/>
-        </p:nvSpPr>
-        <p:spPr>
-          <a:xfrm>
-            <a:off x="11185855" y="6473952"/>
-            <a:ext cx="640080" cy="274320"/>
-          </a:xfrm>
-          <a:prstGeom prst="rect">
-            <a:avLst/>
-          </a:prstGeom>
-          <a:noFill/>
-        </p:spPr>
-        <p:txBody>
-          <a:bodyPr wrap="square">
-            <a:spAutoFit/>
-          </a:bodyPr>
-          <a:lstStyle/>
-          <a:p>
-            <a:pPr algn="r"/>
-            <a:r>
-              <a:rPr sz="1100" b="0" i="0">
-                <a:solidFill>
-                  <a:srgbClr val="666666"/>
-                </a:solidFill>
-                <a:latin typeface="Calibri"/>
-              </a:rPr>
-              <a:t>9</a:t>
+            <a:r>
+              <a:rPr sz="2000" b="1" i="0">
+                <a:solidFill>
+                  <a:srgbClr val="269CCB"/>
+                </a:solidFill>
+                <a:latin typeface="Calibri"/>
+              </a:rPr>
+              <a:t>Pudieron corregir al asistente porque tenían sus decisiones escritas</a:t>
             </a:r>
           </a:p>
         </p:txBody>

</xml_diff>